<commit_message>
fix(helpers): add Thank You fallback to addClosingSlide for logo-less themes
When no logo path is configured, render centered "Thank You" text
instead of leaving the closing slide blank.

Co-Authored-By: Claude Sonnet 4.6 (1M context) <noreply@anthropic.com>
</commit_message>
<xml_diff>
--- a/examples/slides-as-code-design-master/slides-as-code-design-master.pptx
+++ b/examples/slides-as-code-design-master/slides-as-code-design-master.pptx
@@ -2027,6 +2027,45 @@
           <a:chExt cx="0" cy="0"/>
         </a:xfrm>
       </p:grpSpPr>
+      <p:sp>
+        <p:nvSpPr>
+          <p:cNvPr id="2" name="Text 0"/>
+          <p:cNvSpPr/>
+          <p:nvPr/>
+        </p:nvSpPr>
+        <p:spPr>
+          <a:xfrm>
+            <a:off x="914400" y="2880360"/>
+            <a:ext cx="10360152" cy="1097280"/>
+          </a:xfrm>
+          <a:prstGeom prst="rect">
+            <a:avLst/>
+          </a:prstGeom>
+          <a:noFill/>
+          <a:ln/>
+        </p:spPr>
+        <p:txBody>
+          <a:bodyPr wrap="square" rtlCol="0" anchor="ctr"/>
+          <a:lstStyle/>
+          <a:p>
+            <a:pPr algn="ctr" indent="0" marL="0">
+              <a:buNone/>
+            </a:pPr>
+            <a:r>
+              <a:rPr lang="en-US" sz="4800" b="1" dirty="0">
+                <a:solidFill>
+                  <a:srgbClr val="F8FAFC"/>
+                </a:solidFill>
+                <a:latin typeface="Trebuchet MS" pitchFamily="34" charset="0"/>
+                <a:ea typeface="Trebuchet MS" pitchFamily="34" charset="-122"/>
+                <a:cs typeface="Trebuchet MS" pitchFamily="34" charset="-120"/>
+              </a:rPr>
+              <a:t>Thank You</a:t>
+            </a:r>
+            <a:endParaRPr lang="en-US" sz="4800" dirty="0"/>
+          </a:p>
+        </p:txBody>
+      </p:sp>
     </p:spTree>
   </p:cSld>
   <p:clrMapOvr>

</xml_diff>